<commit_message>
Update NFQ notes and results
</commit_message>
<xml_diff>
--- a/03 - Dynamic Programming/slides.pptx
+++ b/03 - Dynamic Programming/slides.pptx
@@ -2,51 +2,51 @@
 <file path=ppt/presentation.xml><?xml version="1.0" encoding="utf-8"?>
 <p:presentation xmlns:a="http://schemas.openxmlformats.org/drawingml/2006/main" xmlns:r="http://schemas.openxmlformats.org/officeDocument/2006/relationships" xmlns:p="http://schemas.openxmlformats.org/presentationml/2006/main" strictFirstAndLastChars="0" embedTrueTypeFonts="1" saveSubsetFonts="1" autoCompressPictures="0">
   <p:sldMasterIdLst>
-    <p:sldMasterId id="2147483659" r:id="rId1"/>
+    <p:sldMasterId id="2147483659" r:id="rId4"/>
   </p:sldMasterIdLst>
   <p:notesMasterIdLst>
-    <p:notesMasterId r:id="rId24"/>
+    <p:notesMasterId r:id="rId27"/>
   </p:notesMasterIdLst>
   <p:sldIdLst>
-    <p:sldId id="256" r:id="rId2"/>
-    <p:sldId id="264" r:id="rId3"/>
-    <p:sldId id="282" r:id="rId4"/>
-    <p:sldId id="265" r:id="rId5"/>
-    <p:sldId id="283" r:id="rId6"/>
-    <p:sldId id="266" r:id="rId7"/>
-    <p:sldId id="267" r:id="rId8"/>
-    <p:sldId id="268" r:id="rId9"/>
-    <p:sldId id="269" r:id="rId10"/>
-    <p:sldId id="270" r:id="rId11"/>
-    <p:sldId id="271" r:id="rId12"/>
-    <p:sldId id="272" r:id="rId13"/>
-    <p:sldId id="274" r:id="rId14"/>
-    <p:sldId id="279" r:id="rId15"/>
-    <p:sldId id="273" r:id="rId16"/>
-    <p:sldId id="281" r:id="rId17"/>
-    <p:sldId id="280" r:id="rId18"/>
-    <p:sldId id="275" r:id="rId19"/>
-    <p:sldId id="276" r:id="rId20"/>
-    <p:sldId id="277" r:id="rId21"/>
-    <p:sldId id="278" r:id="rId22"/>
-    <p:sldId id="285" r:id="rId23"/>
+    <p:sldId id="256" r:id="rId5"/>
+    <p:sldId id="264" r:id="rId6"/>
+    <p:sldId id="282" r:id="rId7"/>
+    <p:sldId id="265" r:id="rId8"/>
+    <p:sldId id="283" r:id="rId9"/>
+    <p:sldId id="266" r:id="rId10"/>
+    <p:sldId id="267" r:id="rId11"/>
+    <p:sldId id="268" r:id="rId12"/>
+    <p:sldId id="269" r:id="rId13"/>
+    <p:sldId id="270" r:id="rId14"/>
+    <p:sldId id="271" r:id="rId15"/>
+    <p:sldId id="272" r:id="rId16"/>
+    <p:sldId id="274" r:id="rId17"/>
+    <p:sldId id="279" r:id="rId18"/>
+    <p:sldId id="273" r:id="rId19"/>
+    <p:sldId id="281" r:id="rId20"/>
+    <p:sldId id="280" r:id="rId21"/>
+    <p:sldId id="275" r:id="rId22"/>
+    <p:sldId id="276" r:id="rId23"/>
+    <p:sldId id="277" r:id="rId24"/>
+    <p:sldId id="278" r:id="rId25"/>
+    <p:sldId id="285" r:id="rId26"/>
   </p:sldIdLst>
   <p:sldSz cx="9144000" cy="6858000" type="screen4x3"/>
   <p:notesSz cx="6858000" cy="9144000"/>
   <p:embeddedFontLst>
     <p:embeddedFont>
       <p:font typeface="Economica" panose="02000506040000020004" pitchFamily="2" charset="77"/>
-      <p:regular r:id="rId25"/>
-      <p:bold r:id="rId26"/>
-      <p:italic r:id="rId27"/>
-      <p:boldItalic r:id="rId28"/>
+      <p:regular r:id="rId28"/>
+      <p:bold r:id="rId29"/>
+      <p:italic r:id="rId30"/>
+      <p:boldItalic r:id="rId31"/>
     </p:embeddedFont>
     <p:embeddedFont>
       <p:font typeface="Open Sans" panose="020B0606030504020204" pitchFamily="34" charset="0"/>
-      <p:regular r:id="rId29"/>
-      <p:bold r:id="rId30"/>
-      <p:italic r:id="rId31"/>
-      <p:boldItalic r:id="rId32"/>
+      <p:regular r:id="rId32"/>
+      <p:bold r:id="rId33"/>
+      <p:italic r:id="rId34"/>
+      <p:boldItalic r:id="rId35"/>
     </p:embeddedFont>
   </p:embeddedFontLst>
   <p:defaultTextStyle>
@@ -284,6 +284,205 @@
     </p:ext>
   </p:extLst>
 </p:presentation>
+</file>
+
+<file path=ppt/revisionInfo.xml><?xml version="1.0" encoding="utf-8"?>
+<p1510:revInfo xmlns:a="http://schemas.openxmlformats.org/drawingml/2006/main" xmlns:r="http://schemas.openxmlformats.org/officeDocument/2006/relationships" xmlns:p1510="http://schemas.microsoft.com/office/powerpoint/2015/10/main">
+  <p1510:revLst>
+    <p1510:client id="{31F05234-7FDF-0341-93BC-2586456163CB}" v="12" dt="2025-10-16T09:31:00.432"/>
+  </p1510:revLst>
+</p1510:revInfo>
+</file>
+
+<file path=ppt/changesInfos/changesInfo1.xml><?xml version="1.0" encoding="utf-8"?>
+<pc:chgInfo xmlns:a="http://schemas.openxmlformats.org/drawingml/2006/main" xmlns:r="http://schemas.openxmlformats.org/officeDocument/2006/relationships" xmlns:ac="http://schemas.microsoft.com/office/drawing/2013/main/command" xmlns:pc="http://schemas.microsoft.com/office/powerpoint/2013/main/command">
+  <pc:docChgLst>
+    <pc:chgData name="Riccardo Berta" userId="c8694f89-bba4-4576-b0a8-456619ca5a8c" providerId="ADAL" clId="{FDDBFC5A-5EA9-5330-BEB8-433D7E3B4C4E}"/>
+    <pc:docChg chg="undo custSel modSld">
+      <pc:chgData name="Riccardo Berta" userId="c8694f89-bba4-4576-b0a8-456619ca5a8c" providerId="ADAL" clId="{FDDBFC5A-5EA9-5330-BEB8-433D7E3B4C4E}" dt="2025-10-16T09:31:31.819" v="204" actId="20577"/>
+      <pc:docMkLst>
+        <pc:docMk/>
+      </pc:docMkLst>
+      <pc:sldChg chg="modSp mod">
+        <pc:chgData name="Riccardo Berta" userId="c8694f89-bba4-4576-b0a8-456619ca5a8c" providerId="ADAL" clId="{FDDBFC5A-5EA9-5330-BEB8-433D7E3B4C4E}" dt="2025-10-08T06:01:12.523" v="136" actId="1076"/>
+        <pc:sldMkLst>
+          <pc:docMk/>
+          <pc:sldMk cId="0" sldId="264"/>
+        </pc:sldMkLst>
+        <pc:spChg chg="mod">
+          <ac:chgData name="Riccardo Berta" userId="c8694f89-bba4-4576-b0a8-456619ca5a8c" providerId="ADAL" clId="{FDDBFC5A-5EA9-5330-BEB8-433D7E3B4C4E}" dt="2025-10-08T06:01:12.523" v="136" actId="1076"/>
+          <ac:spMkLst>
+            <pc:docMk/>
+            <pc:sldMk cId="0" sldId="264"/>
+            <ac:spMk id="84" creationId="{00000000-0000-0000-0000-000000000000}"/>
+          </ac:spMkLst>
+        </pc:spChg>
+      </pc:sldChg>
+      <pc:sldChg chg="modSp mod">
+        <pc:chgData name="Riccardo Berta" userId="c8694f89-bba4-4576-b0a8-456619ca5a8c" providerId="ADAL" clId="{FDDBFC5A-5EA9-5330-BEB8-433D7E3B4C4E}" dt="2025-10-08T05:42:01.099" v="35" actId="1035"/>
+        <pc:sldMkLst>
+          <pc:docMk/>
+          <pc:sldMk cId="3627108427" sldId="266"/>
+        </pc:sldMkLst>
+        <pc:spChg chg="mod">
+          <ac:chgData name="Riccardo Berta" userId="c8694f89-bba4-4576-b0a8-456619ca5a8c" providerId="ADAL" clId="{FDDBFC5A-5EA9-5330-BEB8-433D7E3B4C4E}" dt="2025-10-08T05:41:58.842" v="33" actId="20577"/>
+          <ac:spMkLst>
+            <pc:docMk/>
+            <pc:sldMk cId="3627108427" sldId="266"/>
+            <ac:spMk id="84" creationId="{00000000-0000-0000-0000-000000000000}"/>
+          </ac:spMkLst>
+        </pc:spChg>
+        <pc:picChg chg="mod">
+          <ac:chgData name="Riccardo Berta" userId="c8694f89-bba4-4576-b0a8-456619ca5a8c" providerId="ADAL" clId="{FDDBFC5A-5EA9-5330-BEB8-433D7E3B4C4E}" dt="2025-10-08T05:42:01.099" v="35" actId="1035"/>
+          <ac:picMkLst>
+            <pc:docMk/>
+            <pc:sldMk cId="3627108427" sldId="266"/>
+            <ac:picMk id="2" creationId="{10EAD22E-A8B1-C71A-9169-11571D80F81E}"/>
+          </ac:picMkLst>
+        </pc:picChg>
+      </pc:sldChg>
+      <pc:sldChg chg="modSp mod">
+        <pc:chgData name="Riccardo Berta" userId="c8694f89-bba4-4576-b0a8-456619ca5a8c" providerId="ADAL" clId="{FDDBFC5A-5EA9-5330-BEB8-433D7E3B4C4E}" dt="2025-10-08T05:51:57.129" v="40" actId="20577"/>
+        <pc:sldMkLst>
+          <pc:docMk/>
+          <pc:sldMk cId="3455524310" sldId="271"/>
+        </pc:sldMkLst>
+        <pc:spChg chg="mod">
+          <ac:chgData name="Riccardo Berta" userId="c8694f89-bba4-4576-b0a8-456619ca5a8c" providerId="ADAL" clId="{FDDBFC5A-5EA9-5330-BEB8-433D7E3B4C4E}" dt="2025-10-08T05:51:57.129" v="40" actId="20577"/>
+          <ac:spMkLst>
+            <pc:docMk/>
+            <pc:sldMk cId="3455524310" sldId="271"/>
+            <ac:spMk id="84" creationId="{00000000-0000-0000-0000-000000000000}"/>
+          </ac:spMkLst>
+        </pc:spChg>
+      </pc:sldChg>
+      <pc:sldChg chg="modSp mod">
+        <pc:chgData name="Riccardo Berta" userId="c8694f89-bba4-4576-b0a8-456619ca5a8c" providerId="ADAL" clId="{FDDBFC5A-5EA9-5330-BEB8-433D7E3B4C4E}" dt="2025-10-16T09:20:24.397" v="137" actId="20577"/>
+        <pc:sldMkLst>
+          <pc:docMk/>
+          <pc:sldMk cId="4134572258" sldId="273"/>
+        </pc:sldMkLst>
+        <pc:spChg chg="mod">
+          <ac:chgData name="Riccardo Berta" userId="c8694f89-bba4-4576-b0a8-456619ca5a8c" providerId="ADAL" clId="{FDDBFC5A-5EA9-5330-BEB8-433D7E3B4C4E}" dt="2025-10-16T09:20:24.397" v="137" actId="20577"/>
+          <ac:spMkLst>
+            <pc:docMk/>
+            <pc:sldMk cId="4134572258" sldId="273"/>
+            <ac:spMk id="84" creationId="{00000000-0000-0000-0000-000000000000}"/>
+          </ac:spMkLst>
+        </pc:spChg>
+      </pc:sldChg>
+      <pc:sldChg chg="addSp modSp mod">
+        <pc:chgData name="Riccardo Berta" userId="c8694f89-bba4-4576-b0a8-456619ca5a8c" providerId="ADAL" clId="{FDDBFC5A-5EA9-5330-BEB8-433D7E3B4C4E}" dt="2025-10-08T05:58:55.970" v="126" actId="14100"/>
+        <pc:sldMkLst>
+          <pc:docMk/>
+          <pc:sldMk cId="3676487896" sldId="274"/>
+        </pc:sldMkLst>
+        <pc:spChg chg="mod">
+          <ac:chgData name="Riccardo Berta" userId="c8694f89-bba4-4576-b0a8-456619ca5a8c" providerId="ADAL" clId="{FDDBFC5A-5EA9-5330-BEB8-433D7E3B4C4E}" dt="2025-10-08T05:58:55.970" v="126" actId="14100"/>
+          <ac:spMkLst>
+            <pc:docMk/>
+            <pc:sldMk cId="3676487896" sldId="274"/>
+            <ac:spMk id="84" creationId="{00000000-0000-0000-0000-000000000000}"/>
+          </ac:spMkLst>
+        </pc:spChg>
+        <pc:picChg chg="add mod">
+          <ac:chgData name="Riccardo Berta" userId="c8694f89-bba4-4576-b0a8-456619ca5a8c" providerId="ADAL" clId="{FDDBFC5A-5EA9-5330-BEB8-433D7E3B4C4E}" dt="2025-10-08T05:58:50.450" v="121" actId="1036"/>
+          <ac:picMkLst>
+            <pc:docMk/>
+            <pc:sldMk cId="3676487896" sldId="274"/>
+            <ac:picMk id="4" creationId="{43AF1252-6553-1DAB-A555-5556CF9B9042}"/>
+          </ac:picMkLst>
+        </pc:picChg>
+        <pc:picChg chg="add mod">
+          <ac:chgData name="Riccardo Berta" userId="c8694f89-bba4-4576-b0a8-456619ca5a8c" providerId="ADAL" clId="{FDDBFC5A-5EA9-5330-BEB8-433D7E3B4C4E}" dt="2025-10-08T05:58:50.450" v="121" actId="1036"/>
+          <ac:picMkLst>
+            <pc:docMk/>
+            <pc:sldMk cId="3676487896" sldId="274"/>
+            <ac:picMk id="6" creationId="{94606B6C-6A67-65DA-FEFF-E074B43AD825}"/>
+          </ac:picMkLst>
+        </pc:picChg>
+      </pc:sldChg>
+      <pc:sldChg chg="addSp delSp modSp mod">
+        <pc:chgData name="Riccardo Berta" userId="c8694f89-bba4-4576-b0a8-456619ca5a8c" providerId="ADAL" clId="{FDDBFC5A-5EA9-5330-BEB8-433D7E3B4C4E}" dt="2025-10-16T09:31:31.819" v="204" actId="20577"/>
+        <pc:sldMkLst>
+          <pc:docMk/>
+          <pc:sldMk cId="3124096913" sldId="280"/>
+        </pc:sldMkLst>
+        <pc:spChg chg="mod">
+          <ac:chgData name="Riccardo Berta" userId="c8694f89-bba4-4576-b0a8-456619ca5a8c" providerId="ADAL" clId="{FDDBFC5A-5EA9-5330-BEB8-433D7E3B4C4E}" dt="2025-10-16T09:31:31.819" v="204" actId="20577"/>
+          <ac:spMkLst>
+            <pc:docMk/>
+            <pc:sldMk cId="3124096913" sldId="280"/>
+            <ac:spMk id="84" creationId="{00000000-0000-0000-0000-000000000000}"/>
+          </ac:spMkLst>
+        </pc:spChg>
+        <pc:picChg chg="add mod">
+          <ac:chgData name="Riccardo Berta" userId="c8694f89-bba4-4576-b0a8-456619ca5a8c" providerId="ADAL" clId="{FDDBFC5A-5EA9-5330-BEB8-433D7E3B4C4E}" dt="2025-10-16T09:29:10.559" v="151" actId="1076"/>
+          <ac:picMkLst>
+            <pc:docMk/>
+            <pc:sldMk cId="3124096913" sldId="280"/>
+            <ac:picMk id="3" creationId="{6707F2D1-1D4B-E38F-BC3E-D4B10689BAC6}"/>
+          </ac:picMkLst>
+        </pc:picChg>
+        <pc:picChg chg="add del mod">
+          <ac:chgData name="Riccardo Berta" userId="c8694f89-bba4-4576-b0a8-456619ca5a8c" providerId="ADAL" clId="{FDDBFC5A-5EA9-5330-BEB8-433D7E3B4C4E}" dt="2025-10-16T09:29:36.946" v="175" actId="478"/>
+          <ac:picMkLst>
+            <pc:docMk/>
+            <pc:sldMk cId="3124096913" sldId="280"/>
+            <ac:picMk id="5" creationId="{720CF1D4-4856-9762-3FFB-E1166F0A9987}"/>
+          </ac:picMkLst>
+        </pc:picChg>
+        <pc:picChg chg="add mod">
+          <ac:chgData name="Riccardo Berta" userId="c8694f89-bba4-4576-b0a8-456619ca5a8c" providerId="ADAL" clId="{FDDBFC5A-5EA9-5330-BEB8-433D7E3B4C4E}" dt="2025-10-16T09:30:18.601" v="180" actId="14100"/>
+          <ac:picMkLst>
+            <pc:docMk/>
+            <pc:sldMk cId="3124096913" sldId="280"/>
+            <ac:picMk id="7" creationId="{71B0C712-1CC0-0F6A-76C9-42A9E61DEA09}"/>
+          </ac:picMkLst>
+        </pc:picChg>
+        <pc:picChg chg="add mod">
+          <ac:chgData name="Riccardo Berta" userId="c8694f89-bba4-4576-b0a8-456619ca5a8c" providerId="ADAL" clId="{FDDBFC5A-5EA9-5330-BEB8-433D7E3B4C4E}" dt="2025-10-16T09:30:30.127" v="185" actId="14100"/>
+          <ac:picMkLst>
+            <pc:docMk/>
+            <pc:sldMk cId="3124096913" sldId="280"/>
+            <ac:picMk id="9" creationId="{AE0B0409-0C3D-3321-0BE6-42F87784C5B5}"/>
+          </ac:picMkLst>
+        </pc:picChg>
+      </pc:sldChg>
+      <pc:sldChg chg="addSp delSp modSp mod">
+        <pc:chgData name="Riccardo Berta" userId="c8694f89-bba4-4576-b0a8-456619ca5a8c" providerId="ADAL" clId="{FDDBFC5A-5EA9-5330-BEB8-433D7E3B4C4E}" dt="2025-10-08T05:39:56.902" v="26" actId="1037"/>
+        <pc:sldMkLst>
+          <pc:docMk/>
+          <pc:sldMk cId="1696908413" sldId="283"/>
+        </pc:sldMkLst>
+        <pc:spChg chg="mod">
+          <ac:chgData name="Riccardo Berta" userId="c8694f89-bba4-4576-b0a8-456619ca5a8c" providerId="ADAL" clId="{FDDBFC5A-5EA9-5330-BEB8-433D7E3B4C4E}" dt="2025-10-08T05:39:37.946" v="22" actId="1035"/>
+          <ac:spMkLst>
+            <pc:docMk/>
+            <pc:sldMk cId="1696908413" sldId="283"/>
+            <ac:spMk id="84" creationId="{00000000-0000-0000-0000-000000000000}"/>
+          </ac:spMkLst>
+        </pc:spChg>
+        <pc:picChg chg="add mod">
+          <ac:chgData name="Riccardo Berta" userId="c8694f89-bba4-4576-b0a8-456619ca5a8c" providerId="ADAL" clId="{FDDBFC5A-5EA9-5330-BEB8-433D7E3B4C4E}" dt="2025-10-08T05:39:37.946" v="22" actId="1035"/>
+          <ac:picMkLst>
+            <pc:docMk/>
+            <pc:sldMk cId="1696908413" sldId="283"/>
+            <ac:picMk id="7" creationId="{46FC78C6-5162-FE8D-419F-65781E8BA623}"/>
+          </ac:picMkLst>
+        </pc:picChg>
+        <pc:picChg chg="add mod">
+          <ac:chgData name="Riccardo Berta" userId="c8694f89-bba4-4576-b0a8-456619ca5a8c" providerId="ADAL" clId="{FDDBFC5A-5EA9-5330-BEB8-433D7E3B4C4E}" dt="2025-10-08T05:39:56.902" v="26" actId="1037"/>
+          <ac:picMkLst>
+            <pc:docMk/>
+            <pc:sldMk cId="1696908413" sldId="283"/>
+            <ac:picMk id="10" creationId="{536DCD24-CBA6-0AB8-26E1-185DCE701E5A}"/>
+          </ac:picMkLst>
+        </pc:picChg>
+      </pc:sldChg>
+    </pc:docChg>
+  </pc:docChgLst>
+</pc:chgInfo>
 </file>
 
 <file path=ppt/notesMasters/notesMaster1.xml><?xml version="1.0" encoding="utf-8"?>
@@ -3174,6 +3373,13 @@
             <a:tailEnd type="none" w="sm" len="sm"/>
           </a:ln>
         </p:spPr>
+        <p:txBody>
+          <a:bodyPr/>
+          <a:lstStyle/>
+          <a:p>
+            <a:endParaRPr lang="it-IT"/>
+          </a:p>
+        </p:txBody>
       </p:sp>
       <p:sp>
         <p:nvSpPr>
@@ -3217,6 +3423,13 @@
             <a:tailEnd type="none" w="sm" len="sm"/>
           </a:ln>
         </p:spPr>
+        <p:txBody>
+          <a:bodyPr/>
+          <a:lstStyle/>
+          <a:p>
+            <a:endParaRPr lang="it-IT"/>
+          </a:p>
+        </p:txBody>
       </p:sp>
       <p:sp>
         <p:nvSpPr>
@@ -8685,14 +8898,14 @@
             <a:pPr lvl="1"/>
             <a:r>
               <a:rPr lang="en-GB" dirty="0"/>
+              <a:t>the Markov property</a:t>
+            </a:r>
+          </a:p>
+          <a:p>
+            <a:pPr lvl="1"/>
+            <a:r>
+              <a:rPr lang="en-GB" dirty="0"/>
               <a:t>we have enough computational resources to complete the computation of the solution</a:t>
-            </a:r>
-          </a:p>
-          <a:p>
-            <a:pPr lvl="1"/>
-            <a:r>
-              <a:rPr lang="en-GB" dirty="0"/>
-              <a:t>the Markov property</a:t>
             </a:r>
           </a:p>
           <a:p>
@@ -9211,8 +9424,8 @@
         </p:nvSpPr>
         <p:spPr>
           <a:xfrm>
-            <a:off x="162750" y="930148"/>
-            <a:ext cx="8818500" cy="5672357"/>
+            <a:off x="162750" y="1165536"/>
+            <a:ext cx="8818500" cy="5271231"/>
           </a:xfrm>
           <a:prstGeom prst="rect">
             <a:avLst/>
@@ -9231,6 +9444,44 @@
             </a:r>
           </a:p>
           <a:p>
+            <a:pPr lvl="1"/>
+            <a:r>
+              <a:rPr lang="en-GB" dirty="0"/>
+              <a:t>go-get-it:</a:t>
+            </a:r>
+          </a:p>
+          <a:p>
+            <a:pPr lvl="1"/>
+            <a:endParaRPr lang="en-GB" dirty="0"/>
+          </a:p>
+          <a:p>
+            <a:pPr lvl="1"/>
+            <a:endParaRPr lang="en-GB" dirty="0"/>
+          </a:p>
+          <a:p>
+            <a:pPr lvl="1"/>
+            <a:endParaRPr lang="en-GB" dirty="0"/>
+          </a:p>
+          <a:p>
+            <a:pPr lvl="1"/>
+            <a:r>
+              <a:rPr lang="en-GB" dirty="0"/>
+              <a:t>Careful: </a:t>
+            </a:r>
+          </a:p>
+          <a:p>
+            <a:pPr lvl="1"/>
+            <a:endParaRPr lang="en-GB" dirty="0"/>
+          </a:p>
+          <a:p>
+            <a:pPr lvl="1"/>
+            <a:endParaRPr lang="en-GB" dirty="0"/>
+          </a:p>
+          <a:p>
+            <a:pPr lvl="1"/>
+            <a:endParaRPr lang="en-GB" dirty="0"/>
+          </a:p>
+          <a:p>
             <a:endParaRPr lang="en-GB" sz="500" dirty="0"/>
           </a:p>
           <a:p>
@@ -9238,6 +9489,12 @@
               <a:rPr lang="en-GB" dirty="0"/>
               <a:t>As already seen, Go-get-it policy doesn’t pay well in the FL environment! Whereas the Careful policy is much better. </a:t>
             </a:r>
+          </a:p>
+          <a:p>
+            <a:pPr marL="120650" indent="0">
+              <a:buNone/>
+            </a:pPr>
+            <a:endParaRPr lang="en-GB" dirty="0"/>
           </a:p>
           <a:p>
             <a:r>
@@ -9254,7 +9511,9 @@
             </a:r>
           </a:p>
           <a:p>
-            <a:pPr lvl="1"/>
+            <a:pPr marL="590550" lvl="1" indent="0">
+              <a:buNone/>
+            </a:pPr>
             <a:endParaRPr lang="en-GB" dirty="0"/>
           </a:p>
         </p:txBody>
@@ -9283,6 +9542,66 @@
           <a:xfrm>
             <a:off x="8596852" y="87408"/>
             <a:ext cx="407258" cy="495579"/>
+          </a:xfrm>
+          <a:prstGeom prst="rect">
+            <a:avLst/>
+          </a:prstGeom>
+        </p:spPr>
+      </p:pic>
+      <p:pic>
+        <p:nvPicPr>
+          <p:cNvPr id="4" name="Immagine 3" descr="Immagine che contiene testo, Carattere, schermata, bianco&#10;&#10;Il contenuto generato dall'IA potrebbe non essere corretto.">
+            <a:extLst>
+              <a:ext uri="{FF2B5EF4-FFF2-40B4-BE49-F238E27FC236}">
+                <a16:creationId xmlns:a16="http://schemas.microsoft.com/office/drawing/2014/main" id="{43AF1252-6553-1DAB-A555-5556CF9B9042}"/>
+              </a:ext>
+            </a:extLst>
+          </p:cNvPr>
+          <p:cNvPicPr>
+            <a:picLocks noChangeAspect="1"/>
+          </p:cNvPicPr>
+          <p:nvPr/>
+        </p:nvPicPr>
+        <p:blipFill>
+          <a:blip r:embed="rId4"/>
+          <a:stretch>
+            <a:fillRect/>
+          </a:stretch>
+        </p:blipFill>
+        <p:spPr>
+          <a:xfrm>
+            <a:off x="2003897" y="1943957"/>
+            <a:ext cx="3289300" cy="1409700"/>
+          </a:xfrm>
+          <a:prstGeom prst="rect">
+            <a:avLst/>
+          </a:prstGeom>
+        </p:spPr>
+      </p:pic>
+      <p:pic>
+        <p:nvPicPr>
+          <p:cNvPr id="6" name="Immagine 5" descr="Immagine che contiene testo, Carattere, schermata, bianco&#10;&#10;Il contenuto generato dall'IA potrebbe non essere corretto.">
+            <a:extLst>
+              <a:ext uri="{FF2B5EF4-FFF2-40B4-BE49-F238E27FC236}">
+                <a16:creationId xmlns:a16="http://schemas.microsoft.com/office/drawing/2014/main" id="{94606B6C-6A67-65DA-FEFF-E074B43AD825}"/>
+              </a:ext>
+            </a:extLst>
+          </p:cNvPr>
+          <p:cNvPicPr>
+            <a:picLocks noChangeAspect="1"/>
+          </p:cNvPicPr>
+          <p:nvPr/>
+        </p:nvPicPr>
+        <p:blipFill>
+          <a:blip r:embed="rId5"/>
+          <a:stretch>
+            <a:fillRect/>
+          </a:stretch>
+        </p:blipFill>
+        <p:spPr>
+          <a:xfrm>
+            <a:off x="2003897" y="3451631"/>
+            <a:ext cx="3314700" cy="1409700"/>
           </a:xfrm>
           <a:prstGeom prst="rect">
             <a:avLst/>
@@ -9717,6 +10036,10 @@
           </a:p>
           <a:p>
             <a:pPr lvl="0"/>
+            <a:endParaRPr lang="en-GB" dirty="0"/>
+          </a:p>
+          <a:p>
+            <a:pPr lvl="0"/>
             <a:r>
               <a:rPr lang="en-GB" dirty="0"/>
               <a:t>The process of </a:t>
@@ -10098,8 +10421,87 @@
             <a:pPr lvl="0"/>
             <a:r>
               <a:rPr lang="en-GB" dirty="0"/>
-              <a:t> Is this policy any better? Well, policy evaluation can tell us</a:t>
-            </a:r>
+              <a:t>Is this policy any better? Well, policy evaluation can tell us</a:t>
+            </a:r>
+          </a:p>
+          <a:p>
+            <a:pPr lvl="0"/>
+            <a:r>
+              <a:rPr lang="en-GB" dirty="0"/>
+              <a:t>Careful:</a:t>
+            </a:r>
+          </a:p>
+          <a:p>
+            <a:pPr lvl="0"/>
+            <a:endParaRPr lang="en-GB" dirty="0"/>
+          </a:p>
+          <a:p>
+            <a:pPr lvl="0"/>
+            <a:endParaRPr lang="en-GB" dirty="0"/>
+          </a:p>
+          <a:p>
+            <a:pPr lvl="0"/>
+            <a:endParaRPr lang="en-GB" dirty="0"/>
+          </a:p>
+          <a:p>
+            <a:pPr lvl="0"/>
+            <a:endParaRPr lang="en-GB" dirty="0"/>
+          </a:p>
+          <a:p>
+            <a:pPr lvl="0"/>
+            <a:endParaRPr lang="en-GB" dirty="0"/>
+          </a:p>
+          <a:p>
+            <a:pPr marL="120650" lvl="0" indent="0">
+              <a:buNone/>
+            </a:pPr>
+            <a:endParaRPr lang="en-GB" dirty="0"/>
+          </a:p>
+          <a:p>
+            <a:pPr lvl="0"/>
+            <a:r>
+              <a:rPr lang="en-GB" dirty="0" err="1"/>
+              <a:t>Carefull</a:t>
+            </a:r>
+            <a:r>
+              <a:rPr lang="en-GB" dirty="0"/>
+              <a:t>+:</a:t>
+            </a:r>
+          </a:p>
+          <a:p>
+            <a:pPr lvl="0"/>
+            <a:endParaRPr lang="en-GB" dirty="0"/>
+          </a:p>
+          <a:p>
+            <a:pPr lvl="0"/>
+            <a:endParaRPr lang="en-GB" dirty="0"/>
+          </a:p>
+          <a:p>
+            <a:pPr lvl="0"/>
+            <a:endParaRPr lang="en-GB" dirty="0"/>
+          </a:p>
+          <a:p>
+            <a:pPr lvl="0"/>
+            <a:endParaRPr lang="en-GB" dirty="0"/>
+          </a:p>
+          <a:p>
+            <a:pPr lvl="0"/>
+            <a:endParaRPr lang="en-GB" dirty="0"/>
+          </a:p>
+          <a:p>
+            <a:pPr lvl="0"/>
+            <a:endParaRPr lang="en-GB" dirty="0"/>
+          </a:p>
+          <a:p>
+            <a:r>
+              <a:rPr lang="en-GB" noProof="0" dirty="0"/>
+              <a:t>The new policy is better than the original one!</a:t>
+            </a:r>
+            <a:endParaRPr lang="en-GB" dirty="0"/>
+          </a:p>
+          <a:p>
+            <a:pPr lvl="0"/>
+            <a:endParaRPr lang="en-GB" dirty="0"/>
           </a:p>
           <a:p>
             <a:pPr lvl="0"/>
@@ -10147,6 +10549,96 @@
           <a:xfrm>
             <a:off x="8596852" y="87408"/>
             <a:ext cx="407258" cy="495579"/>
+          </a:xfrm>
+          <a:prstGeom prst="rect">
+            <a:avLst/>
+          </a:prstGeom>
+        </p:spPr>
+      </p:pic>
+      <p:pic>
+        <p:nvPicPr>
+          <p:cNvPr id="3" name="Immagine 2" descr="Immagine che contiene testo, Carattere, schermata, bianco&#10;&#10;Il contenuto generato dall'IA potrebbe non essere corretto.">
+            <a:extLst>
+              <a:ext uri="{FF2B5EF4-FFF2-40B4-BE49-F238E27FC236}">
+                <a16:creationId xmlns:a16="http://schemas.microsoft.com/office/drawing/2014/main" id="{6707F2D1-1D4B-E38F-BC3E-D4B10689BAC6}"/>
+              </a:ext>
+            </a:extLst>
+          </p:cNvPr>
+          <p:cNvPicPr>
+            <a:picLocks noChangeAspect="1"/>
+          </p:cNvPicPr>
+          <p:nvPr/>
+        </p:nvPicPr>
+        <p:blipFill>
+          <a:blip r:embed="rId4"/>
+          <a:stretch>
+            <a:fillRect/>
+          </a:stretch>
+        </p:blipFill>
+        <p:spPr>
+          <a:xfrm>
+            <a:off x="788046" y="1874039"/>
+            <a:ext cx="3314700" cy="1409700"/>
+          </a:xfrm>
+          <a:prstGeom prst="rect">
+            <a:avLst/>
+          </a:prstGeom>
+        </p:spPr>
+      </p:pic>
+      <p:pic>
+        <p:nvPicPr>
+          <p:cNvPr id="7" name="Immagine 6" descr="Immagine che contiene testo, Carattere, bianco, schermata&#10;&#10;Il contenuto generato dall'IA potrebbe non essere corretto.">
+            <a:extLst>
+              <a:ext uri="{FF2B5EF4-FFF2-40B4-BE49-F238E27FC236}">
+                <a16:creationId xmlns:a16="http://schemas.microsoft.com/office/drawing/2014/main" id="{71B0C712-1CC0-0F6A-76C9-42A9E61DEA09}"/>
+              </a:ext>
+            </a:extLst>
+          </p:cNvPr>
+          <p:cNvPicPr>
+            <a:picLocks noChangeAspect="1"/>
+          </p:cNvPicPr>
+          <p:nvPr/>
+        </p:nvPicPr>
+        <p:blipFill>
+          <a:blip r:embed="rId5"/>
+          <a:stretch>
+            <a:fillRect/>
+          </a:stretch>
+        </p:blipFill>
+        <p:spPr>
+          <a:xfrm>
+            <a:off x="982366" y="4075443"/>
+            <a:ext cx="3499834" cy="1570019"/>
+          </a:xfrm>
+          <a:prstGeom prst="rect">
+            <a:avLst/>
+          </a:prstGeom>
+        </p:spPr>
+      </p:pic>
+      <p:pic>
+        <p:nvPicPr>
+          <p:cNvPr id="9" name="Immagine 8" descr="Immagine che contiene testo, Carattere, bianco, schermata&#10;&#10;Il contenuto generato dall'IA potrebbe non essere corretto.">
+            <a:extLst>
+              <a:ext uri="{FF2B5EF4-FFF2-40B4-BE49-F238E27FC236}">
+                <a16:creationId xmlns:a16="http://schemas.microsoft.com/office/drawing/2014/main" id="{AE0B0409-0C3D-3321-0BE6-42F87784C5B5}"/>
+              </a:ext>
+            </a:extLst>
+          </p:cNvPr>
+          <p:cNvPicPr>
+            <a:picLocks noChangeAspect="1"/>
+          </p:cNvPicPr>
+          <p:nvPr/>
+        </p:nvPicPr>
+        <p:blipFill>
+          <a:blip r:embed="rId6"/>
+          <a:stretch>
+            <a:fillRect/>
+          </a:stretch>
+        </p:blipFill>
+        <p:spPr>
+          <a:xfrm>
+            <a:off x="4661802" y="4075442"/>
+            <a:ext cx="3458996" cy="1471247"/>
           </a:xfrm>
           <a:prstGeom prst="rect">
             <a:avLst/>
@@ -10720,7 +11212,7 @@
         </p:nvSpPr>
         <p:spPr>
           <a:xfrm>
-            <a:off x="311700" y="1572899"/>
+            <a:off x="311700" y="1672487"/>
             <a:ext cx="8520600" cy="4239177"/>
           </a:xfrm>
           <a:prstGeom prst="rect">
@@ -10748,25 +11240,20 @@
             <a:endParaRPr lang="en-GB" dirty="0"/>
           </a:p>
           <a:p>
-            <a:pPr lvl="0"/>
             <a:r>
               <a:rPr lang="en-GB" sz="1800" dirty="0"/>
-              <a:t>State-value function</a:t>
-            </a:r>
-            <a:endParaRPr lang="en-GB" dirty="0"/>
+              <a:t>State-value function and </a:t>
+            </a:r>
+            <a:r>
+              <a:rPr lang="en-GB" dirty="0"/>
+              <a:t>Action-value function</a:t>
+            </a:r>
           </a:p>
           <a:p>
             <a:pPr lvl="0"/>
             <a:r>
               <a:rPr lang="en-GB" sz="1800" dirty="0"/>
               <a:t>Bellman equation</a:t>
-            </a:r>
-          </a:p>
-          <a:p>
-            <a:pPr lvl="0"/>
-            <a:r>
-              <a:rPr lang="en-GB" dirty="0"/>
-              <a:t>Action-value function</a:t>
             </a:r>
           </a:p>
           <a:p>
@@ -11891,7 +12378,7 @@
         </p:nvSpPr>
         <p:spPr>
           <a:xfrm>
-            <a:off x="162750" y="1185657"/>
+            <a:off x="162750" y="1421047"/>
             <a:ext cx="8818500" cy="5224230"/>
           </a:xfrm>
           <a:prstGeom prst="rect">
@@ -11989,66 +12476,6 @@
           </a:p>
         </p:txBody>
       </p:sp>
-      <p:pic>
-        <p:nvPicPr>
-          <p:cNvPr id="5" name="Immagine 4">
-            <a:extLst>
-              <a:ext uri="{FF2B5EF4-FFF2-40B4-BE49-F238E27FC236}">
-                <a16:creationId xmlns:a16="http://schemas.microsoft.com/office/drawing/2014/main" id="{4B347B46-0E06-7865-406F-874239C5DAC3}"/>
-              </a:ext>
-            </a:extLst>
-          </p:cNvPr>
-          <p:cNvPicPr>
-            <a:picLocks noChangeAspect="1"/>
-          </p:cNvPicPr>
-          <p:nvPr/>
-        </p:nvPicPr>
-        <p:blipFill>
-          <a:blip r:embed="rId3"/>
-          <a:stretch>
-            <a:fillRect/>
-          </a:stretch>
-        </p:blipFill>
-        <p:spPr>
-          <a:xfrm>
-            <a:off x="934886" y="2645615"/>
-            <a:ext cx="5346700" cy="584200"/>
-          </a:xfrm>
-          <a:prstGeom prst="rect">
-            <a:avLst/>
-          </a:prstGeom>
-        </p:spPr>
-      </p:pic>
-      <p:pic>
-        <p:nvPicPr>
-          <p:cNvPr id="9" name="Immagine 8">
-            <a:extLst>
-              <a:ext uri="{FF2B5EF4-FFF2-40B4-BE49-F238E27FC236}">
-                <a16:creationId xmlns:a16="http://schemas.microsoft.com/office/drawing/2014/main" id="{3BF9E22D-EA10-7BCF-204D-014EFD771D81}"/>
-              </a:ext>
-            </a:extLst>
-          </p:cNvPr>
-          <p:cNvPicPr>
-            <a:picLocks noChangeAspect="1"/>
-          </p:cNvPicPr>
-          <p:nvPr/>
-        </p:nvPicPr>
-        <p:blipFill>
-          <a:blip r:embed="rId4"/>
-          <a:stretch>
-            <a:fillRect/>
-          </a:stretch>
-        </p:blipFill>
-        <p:spPr>
-          <a:xfrm>
-            <a:off x="934886" y="3797772"/>
-            <a:ext cx="5270500" cy="533400"/>
-          </a:xfrm>
-          <a:prstGeom prst="rect">
-            <a:avLst/>
-          </a:prstGeom>
-        </p:spPr>
-      </p:pic>
       <p:pic>
         <p:nvPicPr>
           <p:cNvPr id="2" name="Immagine 1" descr="Immagine che contiene Carattere, Elementi grafici, logo, cerchio&#10;&#10;Descrizione generata automaticamente">
@@ -12064,6 +12491,66 @@
           <p:nvPr/>
         </p:nvPicPr>
         <p:blipFill>
+          <a:blip r:embed="rId3"/>
+          <a:stretch>
+            <a:fillRect/>
+          </a:stretch>
+        </p:blipFill>
+        <p:spPr>
+          <a:xfrm>
+            <a:off x="8596852" y="87408"/>
+            <a:ext cx="407258" cy="495579"/>
+          </a:xfrm>
+          <a:prstGeom prst="rect">
+            <a:avLst/>
+          </a:prstGeom>
+        </p:spPr>
+      </p:pic>
+      <p:pic>
+        <p:nvPicPr>
+          <p:cNvPr id="7" name="Immagine 6">
+            <a:extLst>
+              <a:ext uri="{FF2B5EF4-FFF2-40B4-BE49-F238E27FC236}">
+                <a16:creationId xmlns:a16="http://schemas.microsoft.com/office/drawing/2014/main" id="{46FC78C6-5162-FE8D-419F-65781E8BA623}"/>
+              </a:ext>
+            </a:extLst>
+          </p:cNvPr>
+          <p:cNvPicPr>
+            <a:picLocks noChangeAspect="1"/>
+          </p:cNvPicPr>
+          <p:nvPr/>
+        </p:nvPicPr>
+        <p:blipFill>
+          <a:blip r:embed="rId4"/>
+          <a:stretch>
+            <a:fillRect/>
+          </a:stretch>
+        </p:blipFill>
+        <p:spPr>
+          <a:xfrm>
+            <a:off x="807886" y="3998662"/>
+            <a:ext cx="5549900" cy="558800"/>
+          </a:xfrm>
+          <a:prstGeom prst="rect">
+            <a:avLst/>
+          </a:prstGeom>
+        </p:spPr>
+      </p:pic>
+      <p:pic>
+        <p:nvPicPr>
+          <p:cNvPr id="10" name="Immagine 9">
+            <a:extLst>
+              <a:ext uri="{FF2B5EF4-FFF2-40B4-BE49-F238E27FC236}">
+                <a16:creationId xmlns:a16="http://schemas.microsoft.com/office/drawing/2014/main" id="{536DCD24-CBA6-0AB8-26E1-185DCE701E5A}"/>
+              </a:ext>
+            </a:extLst>
+          </p:cNvPr>
+          <p:cNvPicPr>
+            <a:picLocks noChangeAspect="1"/>
+          </p:cNvPicPr>
+          <p:nvPr/>
+        </p:nvPicPr>
+        <p:blipFill>
           <a:blip r:embed="rId5"/>
           <a:stretch>
             <a:fillRect/>
@@ -12071,8 +12558,8 @@
         </p:blipFill>
         <p:spPr>
           <a:xfrm>
-            <a:off x="8596852" y="87408"/>
-            <a:ext cx="407258" cy="495579"/>
+            <a:off x="773433" y="2893832"/>
+            <a:ext cx="5600700" cy="685800"/>
           </a:xfrm>
           <a:prstGeom prst="rect">
             <a:avLst/>
@@ -12171,7 +12658,15 @@
             <a:pPr lvl="0"/>
             <a:r>
               <a:rPr lang="en-GB" dirty="0"/>
-              <a:t>We can calculate the expected return starting from every single state</a:t>
+              <a:t>We can calculate the </a:t>
+            </a:r>
+            <a:r>
+              <a:rPr lang="en-GB" b="1" dirty="0"/>
+              <a:t>expected return </a:t>
+            </a:r>
+            <a:r>
+              <a:rPr lang="en-GB" dirty="0"/>
+              <a:t>starting from every single state</a:t>
             </a:r>
           </a:p>
           <a:p>
@@ -12282,7 +12777,7 @@
             <a:pPr lvl="0"/>
             <a:r>
               <a:rPr lang="en-GB" dirty="0"/>
-              <a:t>it isn’t straightforward to calculate because of the dependence on other states</a:t>
+              <a:t>It isn’t straightforward to calculate because of the dependence on other states</a:t>
             </a:r>
           </a:p>
           <a:p>
@@ -12367,7 +12862,7 @@
         </p:blipFill>
         <p:spPr>
           <a:xfrm>
-            <a:off x="1930674" y="2920645"/>
+            <a:off x="1930674" y="2902539"/>
             <a:ext cx="5282651" cy="3405322"/>
           </a:xfrm>
           <a:prstGeom prst="rect">
@@ -14044,13 +14539,45 @@
 </file>
 
 <file path=customXml/itemProps1.xml><?xml version="1.0" encoding="utf-8"?>
-<ds:datastoreItem xmlns:ds="http://schemas.openxmlformats.org/officeDocument/2006/customXml" ds:itemID="{72524C1E-9089-472E-A2AE-D19286FA5220}"/>
+<ds:datastoreItem xmlns:ds="http://schemas.openxmlformats.org/officeDocument/2006/customXml" ds:itemID="{72524C1E-9089-472E-A2AE-D19286FA5220}">
+  <ds:schemaRefs>
+    <ds:schemaRef ds:uri="http://schemas.microsoft.com/office/2006/metadata/contentType"/>
+    <ds:schemaRef ds:uri="http://schemas.microsoft.com/office/2006/metadata/properties/metaAttributes"/>
+    <ds:schemaRef ds:uri="http://www.w3.org/2001/XMLSchema"/>
+    <ds:schemaRef ds:uri="http://schemas.microsoft.com/office/2006/metadata/properties"/>
+    <ds:schemaRef ds:uri="3bd0d43f-5e5b-43cd-b6fc-691bd77672c6"/>
+    <ds:schemaRef ds:uri="e9b5433c-2372-4cb7-8bab-09518096b29b"/>
+    <ds:schemaRef ds:uri="http://schemas.microsoft.com/office/2006/documentManagement/types"/>
+    <ds:schemaRef ds:uri="http://schemas.microsoft.com/office/infopath/2007/PartnerControls"/>
+    <ds:schemaRef ds:uri="http://schemas.openxmlformats.org/package/2006/metadata/core-properties"/>
+    <ds:schemaRef ds:uri="http://purl.org/dc/elements/1.1/"/>
+    <ds:schemaRef ds:uri="http://purl.org/dc/terms/"/>
+    <ds:schemaRef ds:uri="http://schemas.microsoft.com/internal/obd"/>
+  </ds:schemaRefs>
+</ds:datastoreItem>
 </file>
 
 <file path=customXml/itemProps2.xml><?xml version="1.0" encoding="utf-8"?>
-<ds:datastoreItem xmlns:ds="http://schemas.openxmlformats.org/officeDocument/2006/customXml" ds:itemID="{72391205-D1CB-427A-B06C-13F8F66A9845}"/>
+<ds:datastoreItem xmlns:ds="http://schemas.openxmlformats.org/officeDocument/2006/customXml" ds:itemID="{72391205-D1CB-427A-B06C-13F8F66A9845}">
+  <ds:schemaRefs>
+    <ds:schemaRef ds:uri="http://schemas.microsoft.com/sharepoint/v3/contenttype/forms"/>
+  </ds:schemaRefs>
+</ds:datastoreItem>
 </file>
 
 <file path=customXml/itemProps3.xml><?xml version="1.0" encoding="utf-8"?>
-<ds:datastoreItem xmlns:ds="http://schemas.openxmlformats.org/officeDocument/2006/customXml" ds:itemID="{2BE1E900-629F-47CF-BF5D-1460205B47BD}"/>
+<ds:datastoreItem xmlns:ds="http://schemas.openxmlformats.org/officeDocument/2006/customXml" ds:itemID="{2BE1E900-629F-47CF-BF5D-1460205B47BD}">
+  <ds:schemaRefs>
+    <ds:schemaRef ds:uri="http://schemas.openxmlformats.org/package/2006/metadata/core-properties"/>
+    <ds:schemaRef ds:uri="http://schemas.microsoft.com/office/2006/metadata/properties"/>
+    <ds:schemaRef ds:uri="http://schemas.microsoft.com/office/infopath/2007/PartnerControls"/>
+    <ds:schemaRef ds:uri="http://purl.org/dc/terms/"/>
+    <ds:schemaRef ds:uri="http://schemas.microsoft.com/office/2006/documentManagement/types"/>
+    <ds:schemaRef ds:uri="http://www.w3.org/XML/1998/namespace"/>
+    <ds:schemaRef ds:uri="3bd0d43f-5e5b-43cd-b6fc-691bd77672c6"/>
+    <ds:schemaRef ds:uri="http://purl.org/dc/elements/1.1/"/>
+    <ds:schemaRef ds:uri="e9b5433c-2372-4cb7-8bab-09518096b29b"/>
+    <ds:schemaRef ds:uri="http://purl.org/dc/dcmitype/"/>
+  </ds:schemaRefs>
+</ds:datastoreItem>
 </file>
</xml_diff>